<commit_message>
Publish uploaded presentation without changes
</commit_message>
<xml_diff>
--- a/assets/Ayalew_Cherenet_Portfolio_Presentation_Flashcards.pptx
+++ b/assets/Ayalew_Cherenet_Portfolio_Presentation_Flashcards.pptx
@@ -2638,39 +2638,6 @@
       </p:sp>
       <p:sp>
         <p:nvSpPr>
-          <p:cNvPr id="3" name="accent-rule-01">
-            <a:extLst xmlns:a="http://schemas.openxmlformats.org/drawingml/2006/main">
-              <a:ext uri="{FF2B5EF4-FFF2-40B4-BE49-F238E27FC236}">
-                <a16:creationId xmlns:a16="http://schemas.microsoft.com/office/drawing/2014/main" id="{A2ACE0B5-41D1-4C3D-BB56-1A87B0C6FD69}"/>
-              </a:ext>
-            </a:extLst>
-          </p:cNvPr>
-          <p:cNvSpPr>
-            <a:spLocks xmlns:a="http://schemas.openxmlformats.org/drawingml/2006/main" noGrp="1"/>
-          </p:cNvSpPr>
-          <p:nvPr/>
-        </p:nvSpPr>
-        <p:spPr>
-          <a:xfrm xmlns:a="http://schemas.openxmlformats.org/drawingml/2006/main">
-            <a:off x="762000" y="704850"/>
-            <a:ext cx="876300" cy="57150"/>
-          </a:xfrm>
-          <a:prstGeom xmlns:a="http://schemas.openxmlformats.org/drawingml/2006/main" prst="roundRect">
-            <a:avLst>
-              <a:gd name="adj" fmla="val 50000"/>
-            </a:avLst>
-          </a:prstGeom>
-          <a:solidFill xmlns:a="http://schemas.openxmlformats.org/drawingml/2006/main">
-            <a:srgbClr val="34D4B4"/>
-          </a:solidFill>
-          <a:ln xmlns:a="http://schemas.openxmlformats.org/drawingml/2006/main" w="0">
-            <a:noFill/>
-            <a:prstDash val="solid"/>
-          </a:ln>
-        </p:spPr>
-      </p:sp>
-      <p:sp>
-        <p:nvSpPr>
           <p:cNvPr id="4" name="footer-01">
             <a:extLst xmlns:a="http://schemas.openxmlformats.org/drawingml/2006/main">
               <a:ext uri="{FF2B5EF4-FFF2-40B4-BE49-F238E27FC236}">
@@ -3328,39 +3295,6 @@
       </p:sp>
       <p:sp>
         <p:nvSpPr>
-          <p:cNvPr id="3" name="accent-rule-10">
-            <a:extLst xmlns:a="http://schemas.openxmlformats.org/drawingml/2006/main">
-              <a:ext uri="{FF2B5EF4-FFF2-40B4-BE49-F238E27FC236}">
-                <a16:creationId xmlns:a16="http://schemas.microsoft.com/office/drawing/2014/main" id="{EE9408A1-BD46-43BD-B790-ED54531BB979}"/>
-              </a:ext>
-            </a:extLst>
-          </p:cNvPr>
-          <p:cNvSpPr>
-            <a:spLocks xmlns:a="http://schemas.openxmlformats.org/drawingml/2006/main" noGrp="1"/>
-          </p:cNvSpPr>
-          <p:nvPr/>
-        </p:nvSpPr>
-        <p:spPr>
-          <a:xfrm xmlns:a="http://schemas.openxmlformats.org/drawingml/2006/main">
-            <a:off x="762000" y="704850"/>
-            <a:ext cx="876300" cy="57150"/>
-          </a:xfrm>
-          <a:prstGeom xmlns:a="http://schemas.openxmlformats.org/drawingml/2006/main" prst="roundRect">
-            <a:avLst>
-              <a:gd name="adj" fmla="val 50000"/>
-            </a:avLst>
-          </a:prstGeom>
-          <a:solidFill xmlns:a="http://schemas.openxmlformats.org/drawingml/2006/main">
-            <a:srgbClr val="34D4B4"/>
-          </a:solidFill>
-          <a:ln xmlns:a="http://schemas.openxmlformats.org/drawingml/2006/main" w="0">
-            <a:noFill/>
-            <a:prstDash val="solid"/>
-          </a:ln>
-        </p:spPr>
-      </p:sp>
-      <p:sp>
-        <p:nvSpPr>
           <p:cNvPr id="4" name="footer-10">
             <a:extLst xmlns:a="http://schemas.openxmlformats.org/drawingml/2006/main">
               <a:ext uri="{FF2B5EF4-FFF2-40B4-BE49-F238E27FC236}">
@@ -3963,39 +3897,6 @@
       </p:sp>
       <p:sp>
         <p:nvSpPr>
-          <p:cNvPr id="3" name="accent-rule-11">
-            <a:extLst xmlns:a="http://schemas.openxmlformats.org/drawingml/2006/main">
-              <a:ext uri="{FF2B5EF4-FFF2-40B4-BE49-F238E27FC236}">
-                <a16:creationId xmlns:a16="http://schemas.microsoft.com/office/drawing/2014/main" id="{61951E47-BB02-4EE1-96B1-5A1F60310478}"/>
-              </a:ext>
-            </a:extLst>
-          </p:cNvPr>
-          <p:cNvSpPr>
-            <a:spLocks xmlns:a="http://schemas.openxmlformats.org/drawingml/2006/main" noGrp="1"/>
-          </p:cNvSpPr>
-          <p:nvPr/>
-        </p:nvSpPr>
-        <p:spPr>
-          <a:xfrm xmlns:a="http://schemas.openxmlformats.org/drawingml/2006/main">
-            <a:off x="762000" y="704850"/>
-            <a:ext cx="876300" cy="57150"/>
-          </a:xfrm>
-          <a:prstGeom xmlns:a="http://schemas.openxmlformats.org/drawingml/2006/main" prst="roundRect">
-            <a:avLst>
-              <a:gd name="adj" fmla="val 50000"/>
-            </a:avLst>
-          </a:prstGeom>
-          <a:solidFill xmlns:a="http://schemas.openxmlformats.org/drawingml/2006/main">
-            <a:srgbClr val="34D4B4"/>
-          </a:solidFill>
-          <a:ln xmlns:a="http://schemas.openxmlformats.org/drawingml/2006/main" w="0">
-            <a:noFill/>
-            <a:prstDash val="solid"/>
-          </a:ln>
-        </p:spPr>
-      </p:sp>
-      <p:sp>
-        <p:nvSpPr>
           <p:cNvPr id="4" name="footer-11">
             <a:extLst xmlns:a="http://schemas.openxmlformats.org/drawingml/2006/main">
               <a:ext uri="{FF2B5EF4-FFF2-40B4-BE49-F238E27FC236}">
@@ -4576,39 +4477,6 @@
       </p:sp>
       <p:sp>
         <p:nvSpPr>
-          <p:cNvPr id="3" name="accent-rule-12">
-            <a:extLst xmlns:a="http://schemas.openxmlformats.org/drawingml/2006/main">
-              <a:ext uri="{FF2B5EF4-FFF2-40B4-BE49-F238E27FC236}">
-                <a16:creationId xmlns:a16="http://schemas.microsoft.com/office/drawing/2014/main" id="{F960DA29-FCDE-4D35-8EBC-E5E8DD51743A}"/>
-              </a:ext>
-            </a:extLst>
-          </p:cNvPr>
-          <p:cNvSpPr>
-            <a:spLocks xmlns:a="http://schemas.openxmlformats.org/drawingml/2006/main" noGrp="1"/>
-          </p:cNvSpPr>
-          <p:nvPr/>
-        </p:nvSpPr>
-        <p:spPr>
-          <a:xfrm xmlns:a="http://schemas.openxmlformats.org/drawingml/2006/main">
-            <a:off x="762000" y="704850"/>
-            <a:ext cx="876300" cy="57150"/>
-          </a:xfrm>
-          <a:prstGeom xmlns:a="http://schemas.openxmlformats.org/drawingml/2006/main" prst="roundRect">
-            <a:avLst>
-              <a:gd name="adj" fmla="val 50000"/>
-            </a:avLst>
-          </a:prstGeom>
-          <a:solidFill xmlns:a="http://schemas.openxmlformats.org/drawingml/2006/main">
-            <a:srgbClr val="34D4B4"/>
-          </a:solidFill>
-          <a:ln xmlns:a="http://schemas.openxmlformats.org/drawingml/2006/main" w="0">
-            <a:noFill/>
-            <a:prstDash val="solid"/>
-          </a:ln>
-        </p:spPr>
-      </p:sp>
-      <p:sp>
-        <p:nvSpPr>
           <p:cNvPr id="4" name="footer-12">
             <a:extLst xmlns:a="http://schemas.openxmlformats.org/drawingml/2006/main">
               <a:ext uri="{FF2B5EF4-FFF2-40B4-BE49-F238E27FC236}">
@@ -5200,39 +5068,6 @@
       </p:sp>
       <p:sp>
         <p:nvSpPr>
-          <p:cNvPr id="3" name="accent-rule-13">
-            <a:extLst xmlns:a="http://schemas.openxmlformats.org/drawingml/2006/main">
-              <a:ext uri="{FF2B5EF4-FFF2-40B4-BE49-F238E27FC236}">
-                <a16:creationId xmlns:a16="http://schemas.microsoft.com/office/drawing/2014/main" id="{F27362B3-923D-4CC0-81B6-8B4DEBC53913}"/>
-              </a:ext>
-            </a:extLst>
-          </p:cNvPr>
-          <p:cNvSpPr>
-            <a:spLocks xmlns:a="http://schemas.openxmlformats.org/drawingml/2006/main" noGrp="1"/>
-          </p:cNvSpPr>
-          <p:nvPr/>
-        </p:nvSpPr>
-        <p:spPr>
-          <a:xfrm xmlns:a="http://schemas.openxmlformats.org/drawingml/2006/main">
-            <a:off x="762000" y="704850"/>
-            <a:ext cx="876300" cy="57150"/>
-          </a:xfrm>
-          <a:prstGeom xmlns:a="http://schemas.openxmlformats.org/drawingml/2006/main" prst="roundRect">
-            <a:avLst>
-              <a:gd name="adj" fmla="val 50000"/>
-            </a:avLst>
-          </a:prstGeom>
-          <a:solidFill xmlns:a="http://schemas.openxmlformats.org/drawingml/2006/main">
-            <a:srgbClr val="34D4B4"/>
-          </a:solidFill>
-          <a:ln xmlns:a="http://schemas.openxmlformats.org/drawingml/2006/main" w="0">
-            <a:noFill/>
-            <a:prstDash val="solid"/>
-          </a:ln>
-        </p:spPr>
-      </p:sp>
-      <p:sp>
-        <p:nvSpPr>
           <p:cNvPr id="4" name="footer-13">
             <a:extLst xmlns:a="http://schemas.openxmlformats.org/drawingml/2006/main">
               <a:ext uri="{FF2B5EF4-FFF2-40B4-BE49-F238E27FC236}">
@@ -5846,39 +5681,6 @@
       </p:sp>
       <p:sp>
         <p:nvSpPr>
-          <p:cNvPr id="3" name="accent-rule-14">
-            <a:extLst xmlns:a="http://schemas.openxmlformats.org/drawingml/2006/main">
-              <a:ext uri="{FF2B5EF4-FFF2-40B4-BE49-F238E27FC236}">
-                <a16:creationId xmlns:a16="http://schemas.microsoft.com/office/drawing/2014/main" id="{9D9F9E12-9F67-483F-A622-6173B3F84B72}"/>
-              </a:ext>
-            </a:extLst>
-          </p:cNvPr>
-          <p:cNvSpPr>
-            <a:spLocks xmlns:a="http://schemas.openxmlformats.org/drawingml/2006/main" noGrp="1"/>
-          </p:cNvSpPr>
-          <p:nvPr/>
-        </p:nvSpPr>
-        <p:spPr>
-          <a:xfrm xmlns:a="http://schemas.openxmlformats.org/drawingml/2006/main">
-            <a:off x="762000" y="704850"/>
-            <a:ext cx="876300" cy="57150"/>
-          </a:xfrm>
-          <a:prstGeom xmlns:a="http://schemas.openxmlformats.org/drawingml/2006/main" prst="roundRect">
-            <a:avLst>
-              <a:gd name="adj" fmla="val 50000"/>
-            </a:avLst>
-          </a:prstGeom>
-          <a:solidFill xmlns:a="http://schemas.openxmlformats.org/drawingml/2006/main">
-            <a:srgbClr val="34D4B4"/>
-          </a:solidFill>
-          <a:ln xmlns:a="http://schemas.openxmlformats.org/drawingml/2006/main" w="0">
-            <a:noFill/>
-            <a:prstDash val="solid"/>
-          </a:ln>
-        </p:spPr>
-      </p:sp>
-      <p:sp>
-        <p:nvSpPr>
           <p:cNvPr id="4" name="footer-14">
             <a:extLst xmlns:a="http://schemas.openxmlformats.org/drawingml/2006/main">
               <a:ext uri="{FF2B5EF4-FFF2-40B4-BE49-F238E27FC236}">
@@ -6459,39 +6261,6 @@
       </p:sp>
       <p:sp>
         <p:nvSpPr>
-          <p:cNvPr id="3" name="accent-rule-15">
-            <a:extLst xmlns:a="http://schemas.openxmlformats.org/drawingml/2006/main">
-              <a:ext uri="{FF2B5EF4-FFF2-40B4-BE49-F238E27FC236}">
-                <a16:creationId xmlns:a16="http://schemas.microsoft.com/office/drawing/2014/main" id="{80181B1E-CAA8-4AA0-B35E-61D7647316F3}"/>
-              </a:ext>
-            </a:extLst>
-          </p:cNvPr>
-          <p:cNvSpPr>
-            <a:spLocks xmlns:a="http://schemas.openxmlformats.org/drawingml/2006/main" noGrp="1"/>
-          </p:cNvSpPr>
-          <p:nvPr/>
-        </p:nvSpPr>
-        <p:spPr>
-          <a:xfrm xmlns:a="http://schemas.openxmlformats.org/drawingml/2006/main">
-            <a:off x="762000" y="704850"/>
-            <a:ext cx="876300" cy="57150"/>
-          </a:xfrm>
-          <a:prstGeom xmlns:a="http://schemas.openxmlformats.org/drawingml/2006/main" prst="roundRect">
-            <a:avLst>
-              <a:gd name="adj" fmla="val 50000"/>
-            </a:avLst>
-          </a:prstGeom>
-          <a:solidFill xmlns:a="http://schemas.openxmlformats.org/drawingml/2006/main">
-            <a:srgbClr val="34D4B4"/>
-          </a:solidFill>
-          <a:ln xmlns:a="http://schemas.openxmlformats.org/drawingml/2006/main" w="0">
-            <a:noFill/>
-            <a:prstDash val="solid"/>
-          </a:ln>
-        </p:spPr>
-      </p:sp>
-      <p:sp>
-        <p:nvSpPr>
           <p:cNvPr id="4" name="footer-15">
             <a:extLst xmlns:a="http://schemas.openxmlformats.org/drawingml/2006/main">
               <a:ext uri="{FF2B5EF4-FFF2-40B4-BE49-F238E27FC236}">
@@ -7649,39 +7418,6 @@
       </p:sp>
       <p:sp>
         <p:nvSpPr>
-          <p:cNvPr id="3" name="accent-rule-02">
-            <a:extLst xmlns:a="http://schemas.openxmlformats.org/drawingml/2006/main">
-              <a:ext uri="{FF2B5EF4-FFF2-40B4-BE49-F238E27FC236}">
-                <a16:creationId xmlns:a16="http://schemas.microsoft.com/office/drawing/2014/main" id="{642A2A71-D68D-43A1-BD24-44A4D084A4FE}"/>
-              </a:ext>
-            </a:extLst>
-          </p:cNvPr>
-          <p:cNvSpPr>
-            <a:spLocks xmlns:a="http://schemas.openxmlformats.org/drawingml/2006/main" noGrp="1"/>
-          </p:cNvSpPr>
-          <p:nvPr/>
-        </p:nvSpPr>
-        <p:spPr>
-          <a:xfrm xmlns:a="http://schemas.openxmlformats.org/drawingml/2006/main">
-            <a:off x="762000" y="704850"/>
-            <a:ext cx="876300" cy="57150"/>
-          </a:xfrm>
-          <a:prstGeom xmlns:a="http://schemas.openxmlformats.org/drawingml/2006/main" prst="roundRect">
-            <a:avLst>
-              <a:gd name="adj" fmla="val 50000"/>
-            </a:avLst>
-          </a:prstGeom>
-          <a:solidFill xmlns:a="http://schemas.openxmlformats.org/drawingml/2006/main">
-            <a:srgbClr val="34D4B4"/>
-          </a:solidFill>
-          <a:ln xmlns:a="http://schemas.openxmlformats.org/drawingml/2006/main" w="0">
-            <a:noFill/>
-            <a:prstDash val="solid"/>
-          </a:ln>
-        </p:spPr>
-      </p:sp>
-      <p:sp>
-        <p:nvSpPr>
           <p:cNvPr id="4" name="footer-02">
             <a:extLst xmlns:a="http://schemas.openxmlformats.org/drawingml/2006/main">
               <a:ext uri="{FF2B5EF4-FFF2-40B4-BE49-F238E27FC236}">
@@ -8262,39 +7998,6 @@
       </p:sp>
       <p:sp>
         <p:nvSpPr>
-          <p:cNvPr id="3" name="accent-rule-03">
-            <a:extLst xmlns:a="http://schemas.openxmlformats.org/drawingml/2006/main">
-              <a:ext uri="{FF2B5EF4-FFF2-40B4-BE49-F238E27FC236}">
-                <a16:creationId xmlns:a16="http://schemas.microsoft.com/office/drawing/2014/main" id="{62B00C5F-B586-41A9-B217-0977B82D0A4B}"/>
-              </a:ext>
-            </a:extLst>
-          </p:cNvPr>
-          <p:cNvSpPr>
-            <a:spLocks xmlns:a="http://schemas.openxmlformats.org/drawingml/2006/main" noGrp="1"/>
-          </p:cNvSpPr>
-          <p:nvPr/>
-        </p:nvSpPr>
-        <p:spPr>
-          <a:xfrm xmlns:a="http://schemas.openxmlformats.org/drawingml/2006/main">
-            <a:off x="762000" y="704850"/>
-            <a:ext cx="876300" cy="57150"/>
-          </a:xfrm>
-          <a:prstGeom xmlns:a="http://schemas.openxmlformats.org/drawingml/2006/main" prst="roundRect">
-            <a:avLst>
-              <a:gd name="adj" fmla="val 50000"/>
-            </a:avLst>
-          </a:prstGeom>
-          <a:solidFill xmlns:a="http://schemas.openxmlformats.org/drawingml/2006/main">
-            <a:srgbClr val="34D4B4"/>
-          </a:solidFill>
-          <a:ln xmlns:a="http://schemas.openxmlformats.org/drawingml/2006/main" w="0">
-            <a:noFill/>
-            <a:prstDash val="solid"/>
-          </a:ln>
-        </p:spPr>
-      </p:sp>
-      <p:sp>
-        <p:nvSpPr>
           <p:cNvPr id="4" name="footer-03">
             <a:extLst xmlns:a="http://schemas.openxmlformats.org/drawingml/2006/main">
               <a:ext uri="{FF2B5EF4-FFF2-40B4-BE49-F238E27FC236}">
@@ -8845,39 +8548,6 @@
       </p:sp>
       <p:sp>
         <p:nvSpPr>
-          <p:cNvPr id="3" name="accent-rule-04">
-            <a:extLst xmlns:a="http://schemas.openxmlformats.org/drawingml/2006/main">
-              <a:ext uri="{FF2B5EF4-FFF2-40B4-BE49-F238E27FC236}">
-                <a16:creationId xmlns:a16="http://schemas.microsoft.com/office/drawing/2014/main" id="{0C257A50-093F-4CB2-BB3A-D11A8DBA5971}"/>
-              </a:ext>
-            </a:extLst>
-          </p:cNvPr>
-          <p:cNvSpPr>
-            <a:spLocks xmlns:a="http://schemas.openxmlformats.org/drawingml/2006/main" noGrp="1"/>
-          </p:cNvSpPr>
-          <p:nvPr/>
-        </p:nvSpPr>
-        <p:spPr>
-          <a:xfrm xmlns:a="http://schemas.openxmlformats.org/drawingml/2006/main">
-            <a:off x="762000" y="704850"/>
-            <a:ext cx="876300" cy="57150"/>
-          </a:xfrm>
-          <a:prstGeom xmlns:a="http://schemas.openxmlformats.org/drawingml/2006/main" prst="roundRect">
-            <a:avLst>
-              <a:gd name="adj" fmla="val 50000"/>
-            </a:avLst>
-          </a:prstGeom>
-          <a:solidFill xmlns:a="http://schemas.openxmlformats.org/drawingml/2006/main">
-            <a:srgbClr val="34D4B4"/>
-          </a:solidFill>
-          <a:ln xmlns:a="http://schemas.openxmlformats.org/drawingml/2006/main" w="0">
-            <a:noFill/>
-            <a:prstDash val="solid"/>
-          </a:ln>
-        </p:spPr>
-      </p:sp>
-      <p:sp>
-        <p:nvSpPr>
           <p:cNvPr id="4" name="footer-04">
             <a:extLst xmlns:a="http://schemas.openxmlformats.org/drawingml/2006/main">
               <a:ext uri="{FF2B5EF4-FFF2-40B4-BE49-F238E27FC236}">
@@ -9469,39 +9139,6 @@
       </p:sp>
       <p:sp>
         <p:nvSpPr>
-          <p:cNvPr id="3" name="accent-rule-05">
-            <a:extLst xmlns:a="http://schemas.openxmlformats.org/drawingml/2006/main">
-              <a:ext uri="{FF2B5EF4-FFF2-40B4-BE49-F238E27FC236}">
-                <a16:creationId xmlns:a16="http://schemas.microsoft.com/office/drawing/2014/main" id="{74C92762-7DA8-4D0B-A64C-09A66B3641D3}"/>
-              </a:ext>
-            </a:extLst>
-          </p:cNvPr>
-          <p:cNvSpPr>
-            <a:spLocks xmlns:a="http://schemas.openxmlformats.org/drawingml/2006/main" noGrp="1"/>
-          </p:cNvSpPr>
-          <p:nvPr/>
-        </p:nvSpPr>
-        <p:spPr>
-          <a:xfrm xmlns:a="http://schemas.openxmlformats.org/drawingml/2006/main">
-            <a:off x="762000" y="704850"/>
-            <a:ext cx="876300" cy="57150"/>
-          </a:xfrm>
-          <a:prstGeom xmlns:a="http://schemas.openxmlformats.org/drawingml/2006/main" prst="roundRect">
-            <a:avLst>
-              <a:gd name="adj" fmla="val 50000"/>
-            </a:avLst>
-          </a:prstGeom>
-          <a:solidFill xmlns:a="http://schemas.openxmlformats.org/drawingml/2006/main">
-            <a:srgbClr val="34D4B4"/>
-          </a:solidFill>
-          <a:ln xmlns:a="http://schemas.openxmlformats.org/drawingml/2006/main" w="0">
-            <a:noFill/>
-            <a:prstDash val="solid"/>
-          </a:ln>
-        </p:spPr>
-      </p:sp>
-      <p:sp>
-        <p:nvSpPr>
           <p:cNvPr id="4" name="footer-05">
             <a:extLst xmlns:a="http://schemas.openxmlformats.org/drawingml/2006/main">
               <a:ext uri="{FF2B5EF4-FFF2-40B4-BE49-F238E27FC236}">
@@ -10137,39 +9774,6 @@
       </p:sp>
       <p:sp>
         <p:nvSpPr>
-          <p:cNvPr id="3" name="accent-rule-06">
-            <a:extLst xmlns:a="http://schemas.openxmlformats.org/drawingml/2006/main">
-              <a:ext uri="{FF2B5EF4-FFF2-40B4-BE49-F238E27FC236}">
-                <a16:creationId xmlns:a16="http://schemas.microsoft.com/office/drawing/2014/main" id="{C9A478B3-DDBF-4C66-A81A-892B978FA36A}"/>
-              </a:ext>
-            </a:extLst>
-          </p:cNvPr>
-          <p:cNvSpPr>
-            <a:spLocks xmlns:a="http://schemas.openxmlformats.org/drawingml/2006/main" noGrp="1"/>
-          </p:cNvSpPr>
-          <p:nvPr/>
-        </p:nvSpPr>
-        <p:spPr>
-          <a:xfrm xmlns:a="http://schemas.openxmlformats.org/drawingml/2006/main">
-            <a:off x="762000" y="704850"/>
-            <a:ext cx="876300" cy="57150"/>
-          </a:xfrm>
-          <a:prstGeom xmlns:a="http://schemas.openxmlformats.org/drawingml/2006/main" prst="roundRect">
-            <a:avLst>
-              <a:gd name="adj" fmla="val 50000"/>
-            </a:avLst>
-          </a:prstGeom>
-          <a:solidFill xmlns:a="http://schemas.openxmlformats.org/drawingml/2006/main">
-            <a:srgbClr val="34D4B4"/>
-          </a:solidFill>
-          <a:ln xmlns:a="http://schemas.openxmlformats.org/drawingml/2006/main" w="0">
-            <a:noFill/>
-            <a:prstDash val="solid"/>
-          </a:ln>
-        </p:spPr>
-      </p:sp>
-      <p:sp>
-        <p:nvSpPr>
           <p:cNvPr id="4" name="footer-06">
             <a:extLst xmlns:a="http://schemas.openxmlformats.org/drawingml/2006/main">
               <a:ext uri="{FF2B5EF4-FFF2-40B4-BE49-F238E27FC236}">
@@ -10761,39 +10365,6 @@
       </p:sp>
       <p:sp>
         <p:nvSpPr>
-          <p:cNvPr id="3" name="accent-rule-07">
-            <a:extLst xmlns:a="http://schemas.openxmlformats.org/drawingml/2006/main">
-              <a:ext uri="{FF2B5EF4-FFF2-40B4-BE49-F238E27FC236}">
-                <a16:creationId xmlns:a16="http://schemas.microsoft.com/office/drawing/2014/main" id="{B7136DA3-E521-4ADC-879B-0C059195FFA8}"/>
-              </a:ext>
-            </a:extLst>
-          </p:cNvPr>
-          <p:cNvSpPr>
-            <a:spLocks xmlns:a="http://schemas.openxmlformats.org/drawingml/2006/main" noGrp="1"/>
-          </p:cNvSpPr>
-          <p:nvPr/>
-        </p:nvSpPr>
-        <p:spPr>
-          <a:xfrm xmlns:a="http://schemas.openxmlformats.org/drawingml/2006/main">
-            <a:off x="762000" y="704850"/>
-            <a:ext cx="876300" cy="57150"/>
-          </a:xfrm>
-          <a:prstGeom xmlns:a="http://schemas.openxmlformats.org/drawingml/2006/main" prst="roundRect">
-            <a:avLst>
-              <a:gd name="adj" fmla="val 50000"/>
-            </a:avLst>
-          </a:prstGeom>
-          <a:solidFill xmlns:a="http://schemas.openxmlformats.org/drawingml/2006/main">
-            <a:srgbClr val="34D4B4"/>
-          </a:solidFill>
-          <a:ln xmlns:a="http://schemas.openxmlformats.org/drawingml/2006/main" w="0">
-            <a:noFill/>
-            <a:prstDash val="solid"/>
-          </a:ln>
-        </p:spPr>
-      </p:sp>
-      <p:sp>
-        <p:nvSpPr>
           <p:cNvPr id="4" name="footer-07">
             <a:extLst xmlns:a="http://schemas.openxmlformats.org/drawingml/2006/main">
               <a:ext uri="{FF2B5EF4-FFF2-40B4-BE49-F238E27FC236}">
@@ -11407,39 +10978,6 @@
       </p:sp>
       <p:sp>
         <p:nvSpPr>
-          <p:cNvPr id="3" name="accent-rule-08">
-            <a:extLst xmlns:a="http://schemas.openxmlformats.org/drawingml/2006/main">
-              <a:ext uri="{FF2B5EF4-FFF2-40B4-BE49-F238E27FC236}">
-                <a16:creationId xmlns:a16="http://schemas.microsoft.com/office/drawing/2014/main" id="{E0C51719-DCB2-482A-86DD-778FEBB2ECB5}"/>
-              </a:ext>
-            </a:extLst>
-          </p:cNvPr>
-          <p:cNvSpPr>
-            <a:spLocks xmlns:a="http://schemas.openxmlformats.org/drawingml/2006/main" noGrp="1"/>
-          </p:cNvSpPr>
-          <p:nvPr/>
-        </p:nvSpPr>
-        <p:spPr>
-          <a:xfrm xmlns:a="http://schemas.openxmlformats.org/drawingml/2006/main">
-            <a:off x="762000" y="704850"/>
-            <a:ext cx="876300" cy="57150"/>
-          </a:xfrm>
-          <a:prstGeom xmlns:a="http://schemas.openxmlformats.org/drawingml/2006/main" prst="roundRect">
-            <a:avLst>
-              <a:gd name="adj" fmla="val 50000"/>
-            </a:avLst>
-          </a:prstGeom>
-          <a:solidFill xmlns:a="http://schemas.openxmlformats.org/drawingml/2006/main">
-            <a:srgbClr val="34D4B4"/>
-          </a:solidFill>
-          <a:ln xmlns:a="http://schemas.openxmlformats.org/drawingml/2006/main" w="0">
-            <a:noFill/>
-            <a:prstDash val="solid"/>
-          </a:ln>
-        </p:spPr>
-      </p:sp>
-      <p:sp>
-        <p:nvSpPr>
           <p:cNvPr id="4" name="footer-08">
             <a:extLst xmlns:a="http://schemas.openxmlformats.org/drawingml/2006/main">
               <a:ext uri="{FF2B5EF4-FFF2-40B4-BE49-F238E27FC236}">
@@ -12028,39 +11566,6 @@
             </a:r>
           </a:p>
         </p:txBody>
-      </p:sp>
-      <p:sp>
-        <p:nvSpPr>
-          <p:cNvPr id="3" name="accent-rule-09">
-            <a:extLst xmlns:a="http://schemas.openxmlformats.org/drawingml/2006/main">
-              <a:ext uri="{FF2B5EF4-FFF2-40B4-BE49-F238E27FC236}">
-                <a16:creationId xmlns:a16="http://schemas.microsoft.com/office/drawing/2014/main" id="{FA09F15B-2F32-4010-A35E-D3485C9DFC00}"/>
-              </a:ext>
-            </a:extLst>
-          </p:cNvPr>
-          <p:cNvSpPr>
-            <a:spLocks xmlns:a="http://schemas.openxmlformats.org/drawingml/2006/main" noGrp="1"/>
-          </p:cNvSpPr>
-          <p:nvPr/>
-        </p:nvSpPr>
-        <p:spPr>
-          <a:xfrm xmlns:a="http://schemas.openxmlformats.org/drawingml/2006/main">
-            <a:off x="762000" y="704850"/>
-            <a:ext cx="876300" cy="57150"/>
-          </a:xfrm>
-          <a:prstGeom xmlns:a="http://schemas.openxmlformats.org/drawingml/2006/main" prst="roundRect">
-            <a:avLst>
-              <a:gd name="adj" fmla="val 50000"/>
-            </a:avLst>
-          </a:prstGeom>
-          <a:solidFill xmlns:a="http://schemas.openxmlformats.org/drawingml/2006/main">
-            <a:srgbClr val="34D4B4"/>
-          </a:solidFill>
-          <a:ln xmlns:a="http://schemas.openxmlformats.org/drawingml/2006/main" w="0">
-            <a:noFill/>
-            <a:prstDash val="solid"/>
-          </a:ln>
-        </p:spPr>
       </p:sp>
       <p:sp>
         <p:nvSpPr>

</xml_diff>